<commit_message>
Add Phase 1 MVP Administrative AI Agent; compress roadmap to 5 months
</commit_message>
<xml_diff>
--- a/AI_Agent_Programme_Roadmap.pptx
+++ b/AI_Agent_Programme_Roadmap.pptx
@@ -3278,7 +3278,7 @@
                 </a:solidFill>
                 <a:latin typeface="Calibri"/>
               </a:rPr>
-              <a:t>6 Phases  -  12 Months  -  Built on Amazon Web Services (AWS)</a:t>
+              <a:t>6 Phases  -  5 Months  -  Built on Amazon Web Services (AWS)</a:t>
             </a:r>
           </a:p>
         </p:txBody>
@@ -3454,7 +3454,7 @@
                 </a:solidFill>
                 <a:latin typeface="Calibri"/>
               </a:rPr>
-              <a:t>Programme Roadmap - 12 Month Timeline</a:t>
+              <a:t>Programme Roadmap - 5 Month Timeline</a:t>
             </a:r>
           </a:p>
         </p:txBody>
@@ -3503,7 +3503,7 @@
         <p:spPr>
           <a:xfrm>
             <a:off x="4023360" y="914400"/>
-            <a:ext cx="655320" cy="411480"/>
+            <a:ext cx="1572768" cy="411480"/>
           </a:xfrm>
           <a:prstGeom prst="rect">
             <a:avLst/>
@@ -3547,7 +3547,7 @@
         <p:spPr>
           <a:xfrm>
             <a:off x="4023360" y="914400"/>
-            <a:ext cx="655320" cy="411480"/>
+            <a:ext cx="1572768" cy="411480"/>
           </a:xfrm>
           <a:prstGeom prst="rect">
             <a:avLst/>
@@ -3581,8 +3581,8 @@
         </p:nvSpPr>
         <p:spPr>
           <a:xfrm>
-            <a:off x="4678680" y="914400"/>
-            <a:ext cx="655320" cy="411480"/>
+            <a:off x="5596128" y="914400"/>
+            <a:ext cx="1572768" cy="411480"/>
           </a:xfrm>
           <a:prstGeom prst="rect">
             <a:avLst/>
@@ -3625,8 +3625,8 @@
         </p:nvSpPr>
         <p:spPr>
           <a:xfrm>
-            <a:off x="4678680" y="914400"/>
-            <a:ext cx="655320" cy="411480"/>
+            <a:off x="5596128" y="914400"/>
+            <a:ext cx="1572768" cy="411480"/>
           </a:xfrm>
           <a:prstGeom prst="rect">
             <a:avLst/>
@@ -3660,8 +3660,8 @@
         </p:nvSpPr>
         <p:spPr>
           <a:xfrm>
-            <a:off x="5334000" y="914400"/>
-            <a:ext cx="655320" cy="411480"/>
+            <a:off x="7168896" y="914400"/>
+            <a:ext cx="1572768" cy="411480"/>
           </a:xfrm>
           <a:prstGeom prst="rect">
             <a:avLst/>
@@ -3704,8 +3704,8 @@
         </p:nvSpPr>
         <p:spPr>
           <a:xfrm>
-            <a:off x="5334000" y="914400"/>
-            <a:ext cx="655320" cy="411480"/>
+            <a:off x="7168896" y="914400"/>
+            <a:ext cx="1572768" cy="411480"/>
           </a:xfrm>
           <a:prstGeom prst="rect">
             <a:avLst/>
@@ -3739,8 +3739,8 @@
         </p:nvSpPr>
         <p:spPr>
           <a:xfrm>
-            <a:off x="5989320" y="914400"/>
-            <a:ext cx="655320" cy="411480"/>
+            <a:off x="8741664" y="914400"/>
+            <a:ext cx="1572768" cy="411480"/>
           </a:xfrm>
           <a:prstGeom prst="rect">
             <a:avLst/>
@@ -3783,8 +3783,8 @@
         </p:nvSpPr>
         <p:spPr>
           <a:xfrm>
-            <a:off x="5989320" y="914400"/>
-            <a:ext cx="655320" cy="411480"/>
+            <a:off x="8741664" y="914400"/>
+            <a:ext cx="1572768" cy="411480"/>
           </a:xfrm>
           <a:prstGeom prst="rect">
             <a:avLst/>
@@ -3818,8 +3818,8 @@
         </p:nvSpPr>
         <p:spPr>
           <a:xfrm>
-            <a:off x="6644640" y="914400"/>
-            <a:ext cx="655320" cy="411480"/>
+            <a:off x="10314432" y="914400"/>
+            <a:ext cx="1572768" cy="411480"/>
           </a:xfrm>
           <a:prstGeom prst="rect">
             <a:avLst/>
@@ -3862,8 +3862,8 @@
         </p:nvSpPr>
         <p:spPr>
           <a:xfrm>
-            <a:off x="6644640" y="914400"/>
-            <a:ext cx="655320" cy="411480"/>
+            <a:off x="10314432" y="914400"/>
+            <a:ext cx="1572768" cy="411480"/>
           </a:xfrm>
           <a:prstGeom prst="rect">
             <a:avLst/>
@@ -3892,559 +3892,6 @@
       <p:sp>
         <p:nvSpPr>
           <p:cNvPr id="16" name="Rectangle 15"/>
-          <p:cNvSpPr/>
-          <p:nvPr/>
-        </p:nvSpPr>
-        <p:spPr>
-          <a:xfrm>
-            <a:off x="7299960" y="914400"/>
-            <a:ext cx="655320" cy="411480"/>
-          </a:xfrm>
-          <a:prstGeom prst="rect">
-            <a:avLst/>
-          </a:prstGeom>
-          <a:solidFill>
-            <a:srgbClr val="F2F4F7"/>
-          </a:solidFill>
-          <a:ln>
-            <a:noFill/>
-          </a:ln>
-          <a:effectLst/>
-        </p:spPr>
-        <p:style>
-          <a:lnRef idx="1">
-            <a:schemeClr val="accent1"/>
-          </a:lnRef>
-          <a:fillRef idx="3">
-            <a:schemeClr val="accent1"/>
-          </a:fillRef>
-          <a:effectRef idx="2">
-            <a:schemeClr val="accent1"/>
-          </a:effectRef>
-          <a:fontRef idx="minor">
-            <a:schemeClr val="lt1"/>
-          </a:fontRef>
-        </p:style>
-        <p:txBody>
-          <a:bodyPr rtlCol="0" anchor="ctr"/>
-          <a:lstStyle/>
-          <a:p>
-            <a:pPr algn="ctr"/>
-          </a:p>
-        </p:txBody>
-      </p:sp>
-      <p:sp>
-        <p:nvSpPr>
-          <p:cNvPr id="17" name="TextBox 16"/>
-          <p:cNvSpPr txBox="1"/>
-          <p:nvPr/>
-        </p:nvSpPr>
-        <p:spPr>
-          <a:xfrm>
-            <a:off x="7299960" y="914400"/>
-            <a:ext cx="655320" cy="411480"/>
-          </a:xfrm>
-          <a:prstGeom prst="rect">
-            <a:avLst/>
-          </a:prstGeom>
-          <a:noFill/>
-        </p:spPr>
-        <p:txBody>
-          <a:bodyPr wrap="square" anchor="ctr" lIns="25400" rIns="25400" tIns="12700" bIns="12700">
-            <a:spAutoFit/>
-          </a:bodyPr>
-          <a:lstStyle/>
-          <a:p>
-            <a:pPr algn="ctr"/>
-            <a:r>
-              <a:rPr sz="1100" b="1" i="0">
-                <a:solidFill>
-                  <a:srgbClr val="1B2430"/>
-                </a:solidFill>
-                <a:latin typeface="Calibri"/>
-              </a:rPr>
-              <a:t>M6</a:t>
-            </a:r>
-          </a:p>
-        </p:txBody>
-      </p:sp>
-      <p:sp>
-        <p:nvSpPr>
-          <p:cNvPr id="18" name="Rectangle 17"/>
-          <p:cNvSpPr/>
-          <p:nvPr/>
-        </p:nvSpPr>
-        <p:spPr>
-          <a:xfrm>
-            <a:off x="7955280" y="914400"/>
-            <a:ext cx="655320" cy="411480"/>
-          </a:xfrm>
-          <a:prstGeom prst="rect">
-            <a:avLst/>
-          </a:prstGeom>
-          <a:solidFill>
-            <a:srgbClr val="F2F4F7"/>
-          </a:solidFill>
-          <a:ln>
-            <a:noFill/>
-          </a:ln>
-          <a:effectLst/>
-        </p:spPr>
-        <p:style>
-          <a:lnRef idx="1">
-            <a:schemeClr val="accent1"/>
-          </a:lnRef>
-          <a:fillRef idx="3">
-            <a:schemeClr val="accent1"/>
-          </a:fillRef>
-          <a:effectRef idx="2">
-            <a:schemeClr val="accent1"/>
-          </a:effectRef>
-          <a:fontRef idx="minor">
-            <a:schemeClr val="lt1"/>
-          </a:fontRef>
-        </p:style>
-        <p:txBody>
-          <a:bodyPr rtlCol="0" anchor="ctr"/>
-          <a:lstStyle/>
-          <a:p>
-            <a:pPr algn="ctr"/>
-          </a:p>
-        </p:txBody>
-      </p:sp>
-      <p:sp>
-        <p:nvSpPr>
-          <p:cNvPr id="19" name="TextBox 18"/>
-          <p:cNvSpPr txBox="1"/>
-          <p:nvPr/>
-        </p:nvSpPr>
-        <p:spPr>
-          <a:xfrm>
-            <a:off x="7955280" y="914400"/>
-            <a:ext cx="655320" cy="411480"/>
-          </a:xfrm>
-          <a:prstGeom prst="rect">
-            <a:avLst/>
-          </a:prstGeom>
-          <a:noFill/>
-        </p:spPr>
-        <p:txBody>
-          <a:bodyPr wrap="square" anchor="ctr" lIns="25400" rIns="25400" tIns="12700" bIns="12700">
-            <a:spAutoFit/>
-          </a:bodyPr>
-          <a:lstStyle/>
-          <a:p>
-            <a:pPr algn="ctr"/>
-            <a:r>
-              <a:rPr sz="1100" b="1" i="0">
-                <a:solidFill>
-                  <a:srgbClr val="1B2430"/>
-                </a:solidFill>
-                <a:latin typeface="Calibri"/>
-              </a:rPr>
-              <a:t>M7</a:t>
-            </a:r>
-          </a:p>
-        </p:txBody>
-      </p:sp>
-      <p:sp>
-        <p:nvSpPr>
-          <p:cNvPr id="20" name="Rectangle 19"/>
-          <p:cNvSpPr/>
-          <p:nvPr/>
-        </p:nvSpPr>
-        <p:spPr>
-          <a:xfrm>
-            <a:off x="8610600" y="914400"/>
-            <a:ext cx="655320" cy="411480"/>
-          </a:xfrm>
-          <a:prstGeom prst="rect">
-            <a:avLst/>
-          </a:prstGeom>
-          <a:solidFill>
-            <a:srgbClr val="F2F4F7"/>
-          </a:solidFill>
-          <a:ln>
-            <a:noFill/>
-          </a:ln>
-          <a:effectLst/>
-        </p:spPr>
-        <p:style>
-          <a:lnRef idx="1">
-            <a:schemeClr val="accent1"/>
-          </a:lnRef>
-          <a:fillRef idx="3">
-            <a:schemeClr val="accent1"/>
-          </a:fillRef>
-          <a:effectRef idx="2">
-            <a:schemeClr val="accent1"/>
-          </a:effectRef>
-          <a:fontRef idx="minor">
-            <a:schemeClr val="lt1"/>
-          </a:fontRef>
-        </p:style>
-        <p:txBody>
-          <a:bodyPr rtlCol="0" anchor="ctr"/>
-          <a:lstStyle/>
-          <a:p>
-            <a:pPr algn="ctr"/>
-          </a:p>
-        </p:txBody>
-      </p:sp>
-      <p:sp>
-        <p:nvSpPr>
-          <p:cNvPr id="21" name="TextBox 20"/>
-          <p:cNvSpPr txBox="1"/>
-          <p:nvPr/>
-        </p:nvSpPr>
-        <p:spPr>
-          <a:xfrm>
-            <a:off x="8610600" y="914400"/>
-            <a:ext cx="655320" cy="411480"/>
-          </a:xfrm>
-          <a:prstGeom prst="rect">
-            <a:avLst/>
-          </a:prstGeom>
-          <a:noFill/>
-        </p:spPr>
-        <p:txBody>
-          <a:bodyPr wrap="square" anchor="ctr" lIns="25400" rIns="25400" tIns="12700" bIns="12700">
-            <a:spAutoFit/>
-          </a:bodyPr>
-          <a:lstStyle/>
-          <a:p>
-            <a:pPr algn="ctr"/>
-            <a:r>
-              <a:rPr sz="1100" b="1" i="0">
-                <a:solidFill>
-                  <a:srgbClr val="1B2430"/>
-                </a:solidFill>
-                <a:latin typeface="Calibri"/>
-              </a:rPr>
-              <a:t>M8</a:t>
-            </a:r>
-          </a:p>
-        </p:txBody>
-      </p:sp>
-      <p:sp>
-        <p:nvSpPr>
-          <p:cNvPr id="22" name="Rectangle 21"/>
-          <p:cNvSpPr/>
-          <p:nvPr/>
-        </p:nvSpPr>
-        <p:spPr>
-          <a:xfrm>
-            <a:off x="9265920" y="914400"/>
-            <a:ext cx="655320" cy="411480"/>
-          </a:xfrm>
-          <a:prstGeom prst="rect">
-            <a:avLst/>
-          </a:prstGeom>
-          <a:solidFill>
-            <a:srgbClr val="F2F4F7"/>
-          </a:solidFill>
-          <a:ln>
-            <a:noFill/>
-          </a:ln>
-          <a:effectLst/>
-        </p:spPr>
-        <p:style>
-          <a:lnRef idx="1">
-            <a:schemeClr val="accent1"/>
-          </a:lnRef>
-          <a:fillRef idx="3">
-            <a:schemeClr val="accent1"/>
-          </a:fillRef>
-          <a:effectRef idx="2">
-            <a:schemeClr val="accent1"/>
-          </a:effectRef>
-          <a:fontRef idx="minor">
-            <a:schemeClr val="lt1"/>
-          </a:fontRef>
-        </p:style>
-        <p:txBody>
-          <a:bodyPr rtlCol="0" anchor="ctr"/>
-          <a:lstStyle/>
-          <a:p>
-            <a:pPr algn="ctr"/>
-          </a:p>
-        </p:txBody>
-      </p:sp>
-      <p:sp>
-        <p:nvSpPr>
-          <p:cNvPr id="23" name="TextBox 22"/>
-          <p:cNvSpPr txBox="1"/>
-          <p:nvPr/>
-        </p:nvSpPr>
-        <p:spPr>
-          <a:xfrm>
-            <a:off x="9265920" y="914400"/>
-            <a:ext cx="655320" cy="411480"/>
-          </a:xfrm>
-          <a:prstGeom prst="rect">
-            <a:avLst/>
-          </a:prstGeom>
-          <a:noFill/>
-        </p:spPr>
-        <p:txBody>
-          <a:bodyPr wrap="square" anchor="ctr" lIns="25400" rIns="25400" tIns="12700" bIns="12700">
-            <a:spAutoFit/>
-          </a:bodyPr>
-          <a:lstStyle/>
-          <a:p>
-            <a:pPr algn="ctr"/>
-            <a:r>
-              <a:rPr sz="1100" b="1" i="0">
-                <a:solidFill>
-                  <a:srgbClr val="1B2430"/>
-                </a:solidFill>
-                <a:latin typeface="Calibri"/>
-              </a:rPr>
-              <a:t>M9</a:t>
-            </a:r>
-          </a:p>
-        </p:txBody>
-      </p:sp>
-      <p:sp>
-        <p:nvSpPr>
-          <p:cNvPr id="24" name="Rectangle 23"/>
-          <p:cNvSpPr/>
-          <p:nvPr/>
-        </p:nvSpPr>
-        <p:spPr>
-          <a:xfrm>
-            <a:off x="9921240" y="914400"/>
-            <a:ext cx="655320" cy="411480"/>
-          </a:xfrm>
-          <a:prstGeom prst="rect">
-            <a:avLst/>
-          </a:prstGeom>
-          <a:solidFill>
-            <a:srgbClr val="F2F4F7"/>
-          </a:solidFill>
-          <a:ln>
-            <a:noFill/>
-          </a:ln>
-          <a:effectLst/>
-        </p:spPr>
-        <p:style>
-          <a:lnRef idx="1">
-            <a:schemeClr val="accent1"/>
-          </a:lnRef>
-          <a:fillRef idx="3">
-            <a:schemeClr val="accent1"/>
-          </a:fillRef>
-          <a:effectRef idx="2">
-            <a:schemeClr val="accent1"/>
-          </a:effectRef>
-          <a:fontRef idx="minor">
-            <a:schemeClr val="lt1"/>
-          </a:fontRef>
-        </p:style>
-        <p:txBody>
-          <a:bodyPr rtlCol="0" anchor="ctr"/>
-          <a:lstStyle/>
-          <a:p>
-            <a:pPr algn="ctr"/>
-          </a:p>
-        </p:txBody>
-      </p:sp>
-      <p:sp>
-        <p:nvSpPr>
-          <p:cNvPr id="25" name="TextBox 24"/>
-          <p:cNvSpPr txBox="1"/>
-          <p:nvPr/>
-        </p:nvSpPr>
-        <p:spPr>
-          <a:xfrm>
-            <a:off x="9921240" y="914400"/>
-            <a:ext cx="655320" cy="411480"/>
-          </a:xfrm>
-          <a:prstGeom prst="rect">
-            <a:avLst/>
-          </a:prstGeom>
-          <a:noFill/>
-        </p:spPr>
-        <p:txBody>
-          <a:bodyPr wrap="square" anchor="ctr" lIns="25400" rIns="25400" tIns="12700" bIns="12700">
-            <a:spAutoFit/>
-          </a:bodyPr>
-          <a:lstStyle/>
-          <a:p>
-            <a:pPr algn="ctr"/>
-            <a:r>
-              <a:rPr sz="1100" b="1" i="0">
-                <a:solidFill>
-                  <a:srgbClr val="1B2430"/>
-                </a:solidFill>
-                <a:latin typeface="Calibri"/>
-              </a:rPr>
-              <a:t>M10</a:t>
-            </a:r>
-          </a:p>
-        </p:txBody>
-      </p:sp>
-      <p:sp>
-        <p:nvSpPr>
-          <p:cNvPr id="26" name="Rectangle 25"/>
-          <p:cNvSpPr/>
-          <p:nvPr/>
-        </p:nvSpPr>
-        <p:spPr>
-          <a:xfrm>
-            <a:off x="10576560" y="914400"/>
-            <a:ext cx="655320" cy="411480"/>
-          </a:xfrm>
-          <a:prstGeom prst="rect">
-            <a:avLst/>
-          </a:prstGeom>
-          <a:solidFill>
-            <a:srgbClr val="F2F4F7"/>
-          </a:solidFill>
-          <a:ln>
-            <a:noFill/>
-          </a:ln>
-          <a:effectLst/>
-        </p:spPr>
-        <p:style>
-          <a:lnRef idx="1">
-            <a:schemeClr val="accent1"/>
-          </a:lnRef>
-          <a:fillRef idx="3">
-            <a:schemeClr val="accent1"/>
-          </a:fillRef>
-          <a:effectRef idx="2">
-            <a:schemeClr val="accent1"/>
-          </a:effectRef>
-          <a:fontRef idx="minor">
-            <a:schemeClr val="lt1"/>
-          </a:fontRef>
-        </p:style>
-        <p:txBody>
-          <a:bodyPr rtlCol="0" anchor="ctr"/>
-          <a:lstStyle/>
-          <a:p>
-            <a:pPr algn="ctr"/>
-          </a:p>
-        </p:txBody>
-      </p:sp>
-      <p:sp>
-        <p:nvSpPr>
-          <p:cNvPr id="27" name="TextBox 26"/>
-          <p:cNvSpPr txBox="1"/>
-          <p:nvPr/>
-        </p:nvSpPr>
-        <p:spPr>
-          <a:xfrm>
-            <a:off x="10576560" y="914400"/>
-            <a:ext cx="655320" cy="411480"/>
-          </a:xfrm>
-          <a:prstGeom prst="rect">
-            <a:avLst/>
-          </a:prstGeom>
-          <a:noFill/>
-        </p:spPr>
-        <p:txBody>
-          <a:bodyPr wrap="square" anchor="ctr" lIns="25400" rIns="25400" tIns="12700" bIns="12700">
-            <a:spAutoFit/>
-          </a:bodyPr>
-          <a:lstStyle/>
-          <a:p>
-            <a:pPr algn="ctr"/>
-            <a:r>
-              <a:rPr sz="1100" b="1" i="0">
-                <a:solidFill>
-                  <a:srgbClr val="1B2430"/>
-                </a:solidFill>
-                <a:latin typeface="Calibri"/>
-              </a:rPr>
-              <a:t>M11</a:t>
-            </a:r>
-          </a:p>
-        </p:txBody>
-      </p:sp>
-      <p:sp>
-        <p:nvSpPr>
-          <p:cNvPr id="28" name="Rectangle 27"/>
-          <p:cNvSpPr/>
-          <p:nvPr/>
-        </p:nvSpPr>
-        <p:spPr>
-          <a:xfrm>
-            <a:off x="11231880" y="914400"/>
-            <a:ext cx="655320" cy="411480"/>
-          </a:xfrm>
-          <a:prstGeom prst="rect">
-            <a:avLst/>
-          </a:prstGeom>
-          <a:solidFill>
-            <a:srgbClr val="F2F4F7"/>
-          </a:solidFill>
-          <a:ln>
-            <a:noFill/>
-          </a:ln>
-          <a:effectLst/>
-        </p:spPr>
-        <p:style>
-          <a:lnRef idx="1">
-            <a:schemeClr val="accent1"/>
-          </a:lnRef>
-          <a:fillRef idx="3">
-            <a:schemeClr val="accent1"/>
-          </a:fillRef>
-          <a:effectRef idx="2">
-            <a:schemeClr val="accent1"/>
-          </a:effectRef>
-          <a:fontRef idx="minor">
-            <a:schemeClr val="lt1"/>
-          </a:fontRef>
-        </p:style>
-        <p:txBody>
-          <a:bodyPr rtlCol="0" anchor="ctr"/>
-          <a:lstStyle/>
-          <a:p>
-            <a:pPr algn="ctr"/>
-          </a:p>
-        </p:txBody>
-      </p:sp>
-      <p:sp>
-        <p:nvSpPr>
-          <p:cNvPr id="29" name="TextBox 28"/>
-          <p:cNvSpPr txBox="1"/>
-          <p:nvPr/>
-        </p:nvSpPr>
-        <p:spPr>
-          <a:xfrm>
-            <a:off x="11231880" y="914400"/>
-            <a:ext cx="655320" cy="411480"/>
-          </a:xfrm>
-          <a:prstGeom prst="rect">
-            <a:avLst/>
-          </a:prstGeom>
-          <a:noFill/>
-        </p:spPr>
-        <p:txBody>
-          <a:bodyPr wrap="square" anchor="ctr" lIns="25400" rIns="25400" tIns="12700" bIns="12700">
-            <a:spAutoFit/>
-          </a:bodyPr>
-          <a:lstStyle/>
-          <a:p>
-            <a:pPr algn="ctr"/>
-            <a:r>
-              <a:rPr sz="1100" b="1" i="0">
-                <a:solidFill>
-                  <a:srgbClr val="1B2430"/>
-                </a:solidFill>
-                <a:latin typeface="Calibri"/>
-              </a:rPr>
-              <a:t>M12</a:t>
-            </a:r>
-          </a:p>
-        </p:txBody>
-      </p:sp>
-      <p:sp>
-        <p:nvSpPr>
-          <p:cNvPr id="30" name="Rectangle 29"/>
           <p:cNvSpPr/>
           <p:nvPr/>
         </p:nvSpPr>
@@ -4488,13 +3935,13 @@
       </p:sp>
       <p:sp>
         <p:nvSpPr>
-          <p:cNvPr id="31" name="Rectangle 30"/>
+          <p:cNvPr id="17" name="Rectangle 16"/>
           <p:cNvSpPr/>
           <p:nvPr/>
         </p:nvSpPr>
         <p:spPr>
           <a:xfrm>
-            <a:off x="4678680" y="1417320"/>
+            <a:off x="5596128" y="1417320"/>
             <a:ext cx="9525" cy="4315968"/>
           </a:xfrm>
           <a:prstGeom prst="rect">
@@ -4532,13 +3979,13 @@
       </p:sp>
       <p:sp>
         <p:nvSpPr>
-          <p:cNvPr id="32" name="Rectangle 31"/>
+          <p:cNvPr id="18" name="Rectangle 17"/>
           <p:cNvSpPr/>
           <p:nvPr/>
         </p:nvSpPr>
         <p:spPr>
           <a:xfrm>
-            <a:off x="5334000" y="1417320"/>
+            <a:off x="7168896" y="1417320"/>
             <a:ext cx="9525" cy="4315968"/>
           </a:xfrm>
           <a:prstGeom prst="rect">
@@ -4576,13 +4023,13 @@
       </p:sp>
       <p:sp>
         <p:nvSpPr>
-          <p:cNvPr id="33" name="Rectangle 32"/>
+          <p:cNvPr id="19" name="Rectangle 18"/>
           <p:cNvSpPr/>
           <p:nvPr/>
         </p:nvSpPr>
         <p:spPr>
           <a:xfrm>
-            <a:off x="5989320" y="1417320"/>
+            <a:off x="8741664" y="1417320"/>
             <a:ext cx="9525" cy="4315968"/>
           </a:xfrm>
           <a:prstGeom prst="rect">
@@ -4620,13 +4067,13 @@
       </p:sp>
       <p:sp>
         <p:nvSpPr>
-          <p:cNvPr id="34" name="Rectangle 33"/>
+          <p:cNvPr id="20" name="Rectangle 19"/>
           <p:cNvSpPr/>
           <p:nvPr/>
         </p:nvSpPr>
         <p:spPr>
           <a:xfrm>
-            <a:off x="6644640" y="1417320"/>
+            <a:off x="10314432" y="1417320"/>
             <a:ext cx="9525" cy="4315968"/>
           </a:xfrm>
           <a:prstGeom prst="rect">
@@ -4664,13 +4111,13 @@
       </p:sp>
       <p:sp>
         <p:nvSpPr>
-          <p:cNvPr id="35" name="Rectangle 34"/>
+          <p:cNvPr id="21" name="Rectangle 20"/>
           <p:cNvSpPr/>
           <p:nvPr/>
         </p:nvSpPr>
         <p:spPr>
           <a:xfrm>
-            <a:off x="7299960" y="1417320"/>
+            <a:off x="11887200" y="1417320"/>
             <a:ext cx="9525" cy="4315968"/>
           </a:xfrm>
           <a:prstGeom prst="rect">
@@ -4708,315 +4155,7 @@
       </p:sp>
       <p:sp>
         <p:nvSpPr>
-          <p:cNvPr id="36" name="Rectangle 35"/>
-          <p:cNvSpPr/>
-          <p:nvPr/>
-        </p:nvSpPr>
-        <p:spPr>
-          <a:xfrm>
-            <a:off x="7955280" y="1417320"/>
-            <a:ext cx="9525" cy="4315968"/>
-          </a:xfrm>
-          <a:prstGeom prst="rect">
-            <a:avLst/>
-          </a:prstGeom>
-          <a:solidFill>
-            <a:srgbClr val="E2E6EA"/>
-          </a:solidFill>
-          <a:ln>
-            <a:noFill/>
-          </a:ln>
-          <a:effectLst/>
-        </p:spPr>
-        <p:style>
-          <a:lnRef idx="1">
-            <a:schemeClr val="accent1"/>
-          </a:lnRef>
-          <a:fillRef idx="3">
-            <a:schemeClr val="accent1"/>
-          </a:fillRef>
-          <a:effectRef idx="2">
-            <a:schemeClr val="accent1"/>
-          </a:effectRef>
-          <a:fontRef idx="minor">
-            <a:schemeClr val="lt1"/>
-          </a:fontRef>
-        </p:style>
-        <p:txBody>
-          <a:bodyPr rtlCol="0" anchor="ctr"/>
-          <a:lstStyle/>
-          <a:p>
-            <a:pPr algn="ctr"/>
-          </a:p>
-        </p:txBody>
-      </p:sp>
-      <p:sp>
-        <p:nvSpPr>
-          <p:cNvPr id="37" name="Rectangle 36"/>
-          <p:cNvSpPr/>
-          <p:nvPr/>
-        </p:nvSpPr>
-        <p:spPr>
-          <a:xfrm>
-            <a:off x="8610600" y="1417320"/>
-            <a:ext cx="9525" cy="4315968"/>
-          </a:xfrm>
-          <a:prstGeom prst="rect">
-            <a:avLst/>
-          </a:prstGeom>
-          <a:solidFill>
-            <a:srgbClr val="E2E6EA"/>
-          </a:solidFill>
-          <a:ln>
-            <a:noFill/>
-          </a:ln>
-          <a:effectLst/>
-        </p:spPr>
-        <p:style>
-          <a:lnRef idx="1">
-            <a:schemeClr val="accent1"/>
-          </a:lnRef>
-          <a:fillRef idx="3">
-            <a:schemeClr val="accent1"/>
-          </a:fillRef>
-          <a:effectRef idx="2">
-            <a:schemeClr val="accent1"/>
-          </a:effectRef>
-          <a:fontRef idx="minor">
-            <a:schemeClr val="lt1"/>
-          </a:fontRef>
-        </p:style>
-        <p:txBody>
-          <a:bodyPr rtlCol="0" anchor="ctr"/>
-          <a:lstStyle/>
-          <a:p>
-            <a:pPr algn="ctr"/>
-          </a:p>
-        </p:txBody>
-      </p:sp>
-      <p:sp>
-        <p:nvSpPr>
-          <p:cNvPr id="38" name="Rectangle 37"/>
-          <p:cNvSpPr/>
-          <p:nvPr/>
-        </p:nvSpPr>
-        <p:spPr>
-          <a:xfrm>
-            <a:off x="9265920" y="1417320"/>
-            <a:ext cx="9525" cy="4315968"/>
-          </a:xfrm>
-          <a:prstGeom prst="rect">
-            <a:avLst/>
-          </a:prstGeom>
-          <a:solidFill>
-            <a:srgbClr val="E2E6EA"/>
-          </a:solidFill>
-          <a:ln>
-            <a:noFill/>
-          </a:ln>
-          <a:effectLst/>
-        </p:spPr>
-        <p:style>
-          <a:lnRef idx="1">
-            <a:schemeClr val="accent1"/>
-          </a:lnRef>
-          <a:fillRef idx="3">
-            <a:schemeClr val="accent1"/>
-          </a:fillRef>
-          <a:effectRef idx="2">
-            <a:schemeClr val="accent1"/>
-          </a:effectRef>
-          <a:fontRef idx="minor">
-            <a:schemeClr val="lt1"/>
-          </a:fontRef>
-        </p:style>
-        <p:txBody>
-          <a:bodyPr rtlCol="0" anchor="ctr"/>
-          <a:lstStyle/>
-          <a:p>
-            <a:pPr algn="ctr"/>
-          </a:p>
-        </p:txBody>
-      </p:sp>
-      <p:sp>
-        <p:nvSpPr>
-          <p:cNvPr id="39" name="Rectangle 38"/>
-          <p:cNvSpPr/>
-          <p:nvPr/>
-        </p:nvSpPr>
-        <p:spPr>
-          <a:xfrm>
-            <a:off x="9921240" y="1417320"/>
-            <a:ext cx="9525" cy="4315968"/>
-          </a:xfrm>
-          <a:prstGeom prst="rect">
-            <a:avLst/>
-          </a:prstGeom>
-          <a:solidFill>
-            <a:srgbClr val="E2E6EA"/>
-          </a:solidFill>
-          <a:ln>
-            <a:noFill/>
-          </a:ln>
-          <a:effectLst/>
-        </p:spPr>
-        <p:style>
-          <a:lnRef idx="1">
-            <a:schemeClr val="accent1"/>
-          </a:lnRef>
-          <a:fillRef idx="3">
-            <a:schemeClr val="accent1"/>
-          </a:fillRef>
-          <a:effectRef idx="2">
-            <a:schemeClr val="accent1"/>
-          </a:effectRef>
-          <a:fontRef idx="minor">
-            <a:schemeClr val="lt1"/>
-          </a:fontRef>
-        </p:style>
-        <p:txBody>
-          <a:bodyPr rtlCol="0" anchor="ctr"/>
-          <a:lstStyle/>
-          <a:p>
-            <a:pPr algn="ctr"/>
-          </a:p>
-        </p:txBody>
-      </p:sp>
-      <p:sp>
-        <p:nvSpPr>
-          <p:cNvPr id="40" name="Rectangle 39"/>
-          <p:cNvSpPr/>
-          <p:nvPr/>
-        </p:nvSpPr>
-        <p:spPr>
-          <a:xfrm>
-            <a:off x="10576560" y="1417320"/>
-            <a:ext cx="9525" cy="4315968"/>
-          </a:xfrm>
-          <a:prstGeom prst="rect">
-            <a:avLst/>
-          </a:prstGeom>
-          <a:solidFill>
-            <a:srgbClr val="E2E6EA"/>
-          </a:solidFill>
-          <a:ln>
-            <a:noFill/>
-          </a:ln>
-          <a:effectLst/>
-        </p:spPr>
-        <p:style>
-          <a:lnRef idx="1">
-            <a:schemeClr val="accent1"/>
-          </a:lnRef>
-          <a:fillRef idx="3">
-            <a:schemeClr val="accent1"/>
-          </a:fillRef>
-          <a:effectRef idx="2">
-            <a:schemeClr val="accent1"/>
-          </a:effectRef>
-          <a:fontRef idx="minor">
-            <a:schemeClr val="lt1"/>
-          </a:fontRef>
-        </p:style>
-        <p:txBody>
-          <a:bodyPr rtlCol="0" anchor="ctr"/>
-          <a:lstStyle/>
-          <a:p>
-            <a:pPr algn="ctr"/>
-          </a:p>
-        </p:txBody>
-      </p:sp>
-      <p:sp>
-        <p:nvSpPr>
-          <p:cNvPr id="41" name="Rectangle 40"/>
-          <p:cNvSpPr/>
-          <p:nvPr/>
-        </p:nvSpPr>
-        <p:spPr>
-          <a:xfrm>
-            <a:off x="11231880" y="1417320"/>
-            <a:ext cx="9525" cy="4315968"/>
-          </a:xfrm>
-          <a:prstGeom prst="rect">
-            <a:avLst/>
-          </a:prstGeom>
-          <a:solidFill>
-            <a:srgbClr val="E2E6EA"/>
-          </a:solidFill>
-          <a:ln>
-            <a:noFill/>
-          </a:ln>
-          <a:effectLst/>
-        </p:spPr>
-        <p:style>
-          <a:lnRef idx="1">
-            <a:schemeClr val="accent1"/>
-          </a:lnRef>
-          <a:fillRef idx="3">
-            <a:schemeClr val="accent1"/>
-          </a:fillRef>
-          <a:effectRef idx="2">
-            <a:schemeClr val="accent1"/>
-          </a:effectRef>
-          <a:fontRef idx="minor">
-            <a:schemeClr val="lt1"/>
-          </a:fontRef>
-        </p:style>
-        <p:txBody>
-          <a:bodyPr rtlCol="0" anchor="ctr"/>
-          <a:lstStyle/>
-          <a:p>
-            <a:pPr algn="ctr"/>
-          </a:p>
-        </p:txBody>
-      </p:sp>
-      <p:sp>
-        <p:nvSpPr>
-          <p:cNvPr id="42" name="Rectangle 41"/>
-          <p:cNvSpPr/>
-          <p:nvPr/>
-        </p:nvSpPr>
-        <p:spPr>
-          <a:xfrm>
-            <a:off x="11887200" y="1417320"/>
-            <a:ext cx="9525" cy="4315968"/>
-          </a:xfrm>
-          <a:prstGeom prst="rect">
-            <a:avLst/>
-          </a:prstGeom>
-          <a:solidFill>
-            <a:srgbClr val="E2E6EA"/>
-          </a:solidFill>
-          <a:ln>
-            <a:noFill/>
-          </a:ln>
-          <a:effectLst/>
-        </p:spPr>
-        <p:style>
-          <a:lnRef idx="1">
-            <a:schemeClr val="accent1"/>
-          </a:lnRef>
-          <a:fillRef idx="3">
-            <a:schemeClr val="accent1"/>
-          </a:fillRef>
-          <a:effectRef idx="2">
-            <a:schemeClr val="accent1"/>
-          </a:effectRef>
-          <a:fontRef idx="minor">
-            <a:schemeClr val="lt1"/>
-          </a:fontRef>
-        </p:style>
-        <p:txBody>
-          <a:bodyPr rtlCol="0" anchor="ctr"/>
-          <a:lstStyle/>
-          <a:p>
-            <a:pPr algn="ctr"/>
-          </a:p>
-        </p:txBody>
-      </p:sp>
-      <p:sp>
-        <p:nvSpPr>
-          <p:cNvPr id="43" name="TextBox 42"/>
+          <p:cNvPr id="22" name="TextBox 21"/>
           <p:cNvSpPr txBox="1"/>
           <p:nvPr/>
         </p:nvSpPr>
@@ -5051,14 +4190,14 @@
       </p:sp>
       <p:sp>
         <p:nvSpPr>
-          <p:cNvPr id="44" name="Rounded Rectangle 43"/>
+          <p:cNvPr id="23" name="Rounded Rectangle 22"/>
           <p:cNvSpPr/>
           <p:nvPr/>
         </p:nvSpPr>
         <p:spPr>
           <a:xfrm>
             <a:off x="4032885" y="1512570"/>
-            <a:ext cx="1291590" cy="467868"/>
+            <a:ext cx="1553718" cy="467868"/>
           </a:xfrm>
           <a:prstGeom prst="roundRect">
             <a:avLst/>
@@ -5095,14 +4234,14 @@
       </p:sp>
       <p:sp>
         <p:nvSpPr>
-          <p:cNvPr id="45" name="TextBox 44"/>
+          <p:cNvPr id="24" name="TextBox 23"/>
           <p:cNvSpPr txBox="1"/>
           <p:nvPr/>
         </p:nvSpPr>
         <p:spPr>
           <a:xfrm>
             <a:off x="4023360" y="1417320"/>
-            <a:ext cx="1310640" cy="658368"/>
+            <a:ext cx="1572768" cy="658368"/>
           </a:xfrm>
           <a:prstGeom prst="rect">
             <a:avLst/>
@@ -5123,14 +4262,14 @@
                 </a:solidFill>
                 <a:latin typeface="Calibri"/>
               </a:rPr>
-              <a:t>M1-M2</a:t>
-            </a:r>
-          </a:p>
-        </p:txBody>
-      </p:sp>
-      <p:sp>
-        <p:nvSpPr>
-          <p:cNvPr id="46" name="TextBox 45"/>
+              <a:t>M1</a:t>
+            </a:r>
+          </a:p>
+        </p:txBody>
+      </p:sp>
+      <p:sp>
+        <p:nvSpPr>
+          <p:cNvPr id="25" name="TextBox 24"/>
           <p:cNvSpPr txBox="1"/>
           <p:nvPr/>
         </p:nvSpPr>
@@ -5165,14 +4304,14 @@
       </p:sp>
       <p:sp>
         <p:nvSpPr>
-          <p:cNvPr id="47" name="Rounded Rectangle 46"/>
+          <p:cNvPr id="26" name="Rounded Rectangle 25"/>
           <p:cNvSpPr/>
           <p:nvPr/>
         </p:nvSpPr>
         <p:spPr>
           <a:xfrm>
-            <a:off x="5343525" y="2244090"/>
-            <a:ext cx="636270" cy="467868"/>
+            <a:off x="5605653" y="2244090"/>
+            <a:ext cx="1553718" cy="467868"/>
           </a:xfrm>
           <a:prstGeom prst="roundRect">
             <a:avLst/>
@@ -5209,14 +4348,14 @@
       </p:sp>
       <p:sp>
         <p:nvSpPr>
-          <p:cNvPr id="48" name="TextBox 47"/>
+          <p:cNvPr id="27" name="TextBox 26"/>
           <p:cNvSpPr txBox="1"/>
           <p:nvPr/>
         </p:nvSpPr>
         <p:spPr>
           <a:xfrm>
-            <a:off x="5334000" y="2148840"/>
-            <a:ext cx="655320" cy="658368"/>
+            <a:off x="5596128" y="2148840"/>
+            <a:ext cx="1572768" cy="658368"/>
           </a:xfrm>
           <a:prstGeom prst="rect">
             <a:avLst/>
@@ -5237,14 +4376,14 @@
                 </a:solidFill>
                 <a:latin typeface="Calibri"/>
               </a:rPr>
-              <a:t>M3</a:t>
-            </a:r>
-          </a:p>
-        </p:txBody>
-      </p:sp>
-      <p:sp>
-        <p:nvSpPr>
-          <p:cNvPr id="49" name="TextBox 48"/>
+              <a:t>M2</a:t>
+            </a:r>
+          </a:p>
+        </p:txBody>
+      </p:sp>
+      <p:sp>
+        <p:nvSpPr>
+          <p:cNvPr id="28" name="TextBox 27"/>
           <p:cNvSpPr txBox="1"/>
           <p:nvPr/>
         </p:nvSpPr>
@@ -5279,14 +4418,14 @@
       </p:sp>
       <p:sp>
         <p:nvSpPr>
-          <p:cNvPr id="50" name="Rounded Rectangle 49"/>
+          <p:cNvPr id="29" name="Rounded Rectangle 28"/>
           <p:cNvSpPr/>
           <p:nvPr/>
         </p:nvSpPr>
         <p:spPr>
           <a:xfrm>
-            <a:off x="5998845" y="2975610"/>
-            <a:ext cx="1291590" cy="467868"/>
+            <a:off x="5605653" y="2975610"/>
+            <a:ext cx="3126486" cy="467868"/>
           </a:xfrm>
           <a:prstGeom prst="roundRect">
             <a:avLst/>
@@ -5323,14 +4462,14 @@
       </p:sp>
       <p:sp>
         <p:nvSpPr>
-          <p:cNvPr id="51" name="TextBox 50"/>
+          <p:cNvPr id="30" name="TextBox 29"/>
           <p:cNvSpPr txBox="1"/>
           <p:nvPr/>
         </p:nvSpPr>
         <p:spPr>
           <a:xfrm>
-            <a:off x="5989320" y="2880360"/>
-            <a:ext cx="1310640" cy="658368"/>
+            <a:off x="5596128" y="2880360"/>
+            <a:ext cx="3145536" cy="658368"/>
           </a:xfrm>
           <a:prstGeom prst="rect">
             <a:avLst/>
@@ -5351,14 +4490,14 @@
                 </a:solidFill>
                 <a:latin typeface="Calibri"/>
               </a:rPr>
-              <a:t>M4-M5</a:t>
-            </a:r>
-          </a:p>
-        </p:txBody>
-      </p:sp>
-      <p:sp>
-        <p:nvSpPr>
-          <p:cNvPr id="52" name="TextBox 51"/>
+              <a:t>M2-M3</a:t>
+            </a:r>
+          </a:p>
+        </p:txBody>
+      </p:sp>
+      <p:sp>
+        <p:nvSpPr>
+          <p:cNvPr id="31" name="TextBox 30"/>
           <p:cNvSpPr txBox="1"/>
           <p:nvPr/>
         </p:nvSpPr>
@@ -5393,14 +4532,14 @@
       </p:sp>
       <p:sp>
         <p:nvSpPr>
-          <p:cNvPr id="53" name="Rounded Rectangle 52"/>
+          <p:cNvPr id="32" name="Rounded Rectangle 31"/>
           <p:cNvSpPr/>
           <p:nvPr/>
         </p:nvSpPr>
         <p:spPr>
           <a:xfrm>
-            <a:off x="7309485" y="3707130"/>
-            <a:ext cx="1291590" cy="467868"/>
+            <a:off x="7178421" y="3707130"/>
+            <a:ext cx="3126486" cy="467868"/>
           </a:xfrm>
           <a:prstGeom prst="roundRect">
             <a:avLst/>
@@ -5437,14 +4576,14 @@
       </p:sp>
       <p:sp>
         <p:nvSpPr>
-          <p:cNvPr id="54" name="TextBox 53"/>
+          <p:cNvPr id="33" name="TextBox 32"/>
           <p:cNvSpPr txBox="1"/>
           <p:nvPr/>
         </p:nvSpPr>
         <p:spPr>
           <a:xfrm>
-            <a:off x="7299960" y="3611880"/>
-            <a:ext cx="1310640" cy="658368"/>
+            <a:off x="7168896" y="3611880"/>
+            <a:ext cx="3145536" cy="658368"/>
           </a:xfrm>
           <a:prstGeom prst="rect">
             <a:avLst/>
@@ -5465,14 +4604,14 @@
                 </a:solidFill>
                 <a:latin typeface="Calibri"/>
               </a:rPr>
-              <a:t>M6-M7</a:t>
-            </a:r>
-          </a:p>
-        </p:txBody>
-      </p:sp>
-      <p:sp>
-        <p:nvSpPr>
-          <p:cNvPr id="55" name="TextBox 54"/>
+              <a:t>M3-M4</a:t>
+            </a:r>
+          </a:p>
+        </p:txBody>
+      </p:sp>
+      <p:sp>
+        <p:nvSpPr>
+          <p:cNvPr id="34" name="TextBox 33"/>
           <p:cNvSpPr txBox="1"/>
           <p:nvPr/>
         </p:nvSpPr>
@@ -5507,14 +4646,14 @@
       </p:sp>
       <p:sp>
         <p:nvSpPr>
-          <p:cNvPr id="56" name="Rounded Rectangle 55"/>
+          <p:cNvPr id="35" name="Rounded Rectangle 34"/>
           <p:cNvSpPr/>
           <p:nvPr/>
         </p:nvSpPr>
         <p:spPr>
           <a:xfrm>
-            <a:off x="8620125" y="4438650"/>
-            <a:ext cx="1291590" cy="467868"/>
+            <a:off x="8751189" y="4438650"/>
+            <a:ext cx="1553718" cy="467868"/>
           </a:xfrm>
           <a:prstGeom prst="roundRect">
             <a:avLst/>
@@ -5551,14 +4690,14 @@
       </p:sp>
       <p:sp>
         <p:nvSpPr>
-          <p:cNvPr id="57" name="TextBox 56"/>
+          <p:cNvPr id="36" name="TextBox 35"/>
           <p:cNvSpPr txBox="1"/>
           <p:nvPr/>
         </p:nvSpPr>
         <p:spPr>
           <a:xfrm>
-            <a:off x="8610600" y="4343400"/>
-            <a:ext cx="1310640" cy="658368"/>
+            <a:off x="8741664" y="4343400"/>
+            <a:ext cx="1572768" cy="658368"/>
           </a:xfrm>
           <a:prstGeom prst="rect">
             <a:avLst/>
@@ -5579,14 +4718,14 @@
                 </a:solidFill>
                 <a:latin typeface="Calibri"/>
               </a:rPr>
-              <a:t>M8-M9</a:t>
-            </a:r>
-          </a:p>
-        </p:txBody>
-      </p:sp>
-      <p:sp>
-        <p:nvSpPr>
-          <p:cNvPr id="58" name="TextBox 57"/>
+              <a:t>M4</a:t>
+            </a:r>
+          </a:p>
+        </p:txBody>
+      </p:sp>
+      <p:sp>
+        <p:nvSpPr>
+          <p:cNvPr id="37" name="TextBox 36"/>
           <p:cNvSpPr txBox="1"/>
           <p:nvPr/>
         </p:nvSpPr>
@@ -5621,14 +4760,14 @@
       </p:sp>
       <p:sp>
         <p:nvSpPr>
-          <p:cNvPr id="59" name="Rounded Rectangle 58"/>
+          <p:cNvPr id="38" name="Rounded Rectangle 37"/>
           <p:cNvSpPr/>
           <p:nvPr/>
         </p:nvSpPr>
         <p:spPr>
           <a:xfrm>
-            <a:off x="9930765" y="5170170"/>
-            <a:ext cx="1946910" cy="467868"/>
+            <a:off x="8751189" y="5170170"/>
+            <a:ext cx="3126486" cy="467868"/>
           </a:xfrm>
           <a:prstGeom prst="roundRect">
             <a:avLst/>
@@ -5665,14 +4804,14 @@
       </p:sp>
       <p:sp>
         <p:nvSpPr>
-          <p:cNvPr id="60" name="TextBox 59"/>
+          <p:cNvPr id="39" name="TextBox 38"/>
           <p:cNvSpPr txBox="1"/>
           <p:nvPr/>
         </p:nvSpPr>
         <p:spPr>
           <a:xfrm>
-            <a:off x="9921240" y="5074920"/>
-            <a:ext cx="1965960" cy="658368"/>
+            <a:off x="8741664" y="5074920"/>
+            <a:ext cx="3145536" cy="658368"/>
           </a:xfrm>
           <a:prstGeom prst="rect">
             <a:avLst/>
@@ -5693,14 +4832,14 @@
                 </a:solidFill>
                 <a:latin typeface="Calibri"/>
               </a:rPr>
-              <a:t>M10-M12</a:t>
-            </a:r>
-          </a:p>
-        </p:txBody>
-      </p:sp>
-      <p:sp>
-        <p:nvSpPr>
-          <p:cNvPr id="61" name="Rectangle 60"/>
+              <a:t>M4-M5</a:t>
+            </a:r>
+          </a:p>
+        </p:txBody>
+      </p:sp>
+      <p:sp>
+        <p:nvSpPr>
+          <p:cNvPr id="40" name="Rectangle 39"/>
           <p:cNvSpPr/>
           <p:nvPr/>
         </p:nvSpPr>
@@ -5744,13 +4883,13 @@
       </p:sp>
       <p:sp>
         <p:nvSpPr>
-          <p:cNvPr id="62" name="Oval 61"/>
+          <p:cNvPr id="41" name="Oval 40"/>
           <p:cNvSpPr/>
           <p:nvPr/>
         </p:nvSpPr>
         <p:spPr>
           <a:xfrm>
-            <a:off x="5251323" y="5733288"/>
+            <a:off x="5513451" y="5733288"/>
             <a:ext cx="146304" cy="146304"/>
           </a:xfrm>
           <a:prstGeom prst="ellipse">
@@ -5788,14 +4927,14 @@
       </p:sp>
       <p:sp>
         <p:nvSpPr>
-          <p:cNvPr id="63" name="TextBox 62"/>
+          <p:cNvPr id="42" name="TextBox 41"/>
           <p:cNvSpPr txBox="1"/>
           <p:nvPr/>
         </p:nvSpPr>
         <p:spPr>
           <a:xfrm>
-            <a:off x="4023360" y="5943600"/>
-            <a:ext cx="1310640" cy="457200"/>
+            <a:off x="2450592" y="5943600"/>
+            <a:ext cx="3145536" cy="457200"/>
           </a:xfrm>
           <a:prstGeom prst="rect">
             <a:avLst/>
@@ -5816,20 +4955,20 @@
                 </a:solidFill>
                 <a:latin typeface="Calibri"/>
               </a:rPr>
-              <a:t>M2: MVP live</a:t>
-            </a:r>
-          </a:p>
-        </p:txBody>
-      </p:sp>
-      <p:sp>
-        <p:nvSpPr>
-          <p:cNvPr id="64" name="Oval 63"/>
+              <a:t>M1: MVP live</a:t>
+            </a:r>
+          </a:p>
+        </p:txBody>
+      </p:sp>
+      <p:sp>
+        <p:nvSpPr>
+          <p:cNvPr id="43" name="Oval 42"/>
           <p:cNvSpPr/>
           <p:nvPr/>
         </p:nvSpPr>
         <p:spPr>
           <a:xfrm>
-            <a:off x="7217283" y="5733288"/>
+            <a:off x="8658987" y="5733288"/>
             <a:ext cx="146304" cy="146304"/>
           </a:xfrm>
           <a:prstGeom prst="ellipse">
@@ -5867,14 +5006,14 @@
       </p:sp>
       <p:sp>
         <p:nvSpPr>
-          <p:cNvPr id="65" name="TextBox 64"/>
+          <p:cNvPr id="44" name="TextBox 43"/>
           <p:cNvSpPr txBox="1"/>
           <p:nvPr/>
         </p:nvSpPr>
         <p:spPr>
           <a:xfrm>
-            <a:off x="5989320" y="5943600"/>
-            <a:ext cx="1310640" cy="457200"/>
+            <a:off x="5596128" y="5943600"/>
+            <a:ext cx="3145536" cy="457200"/>
           </a:xfrm>
           <a:prstGeom prst="rect">
             <a:avLst/>
@@ -5895,20 +5034,20 @@
                 </a:solidFill>
                 <a:latin typeface="Calibri"/>
               </a:rPr>
-              <a:t>M5: Governance insights</a:t>
-            </a:r>
-          </a:p>
-        </p:txBody>
-      </p:sp>
-      <p:sp>
-        <p:nvSpPr>
-          <p:cNvPr id="66" name="Oval 65"/>
+              <a:t>M3: Governance insights</a:t>
+            </a:r>
+          </a:p>
+        </p:txBody>
+      </p:sp>
+      <p:sp>
+        <p:nvSpPr>
+          <p:cNvPr id="45" name="Oval 44"/>
           <p:cNvSpPr/>
           <p:nvPr/>
         </p:nvSpPr>
         <p:spPr>
           <a:xfrm>
-            <a:off x="9838563" y="5733288"/>
+            <a:off x="10231755" y="5733288"/>
             <a:ext cx="146304" cy="146304"/>
           </a:xfrm>
           <a:prstGeom prst="ellipse">
@@ -5946,14 +5085,14 @@
       </p:sp>
       <p:sp>
         <p:nvSpPr>
-          <p:cNvPr id="67" name="TextBox 66"/>
+          <p:cNvPr id="46" name="TextBox 45"/>
           <p:cNvSpPr txBox="1"/>
           <p:nvPr/>
         </p:nvSpPr>
         <p:spPr>
           <a:xfrm>
-            <a:off x="8610600" y="5943600"/>
-            <a:ext cx="1310640" cy="457200"/>
+            <a:off x="7168896" y="5943600"/>
+            <a:ext cx="3145536" cy="457200"/>
           </a:xfrm>
           <a:prstGeom prst="rect">
             <a:avLst/>
@@ -5974,14 +5113,14 @@
                 </a:solidFill>
                 <a:latin typeface="Calibri"/>
               </a:rPr>
-              <a:t>M9: Knowledge Q&amp;A</a:t>
-            </a:r>
-          </a:p>
-        </p:txBody>
-      </p:sp>
-      <p:sp>
-        <p:nvSpPr>
-          <p:cNvPr id="68" name="Oval 67"/>
+              <a:t>M4: Knowledge Q&amp;A</a:t>
+            </a:r>
+          </a:p>
+        </p:txBody>
+      </p:sp>
+      <p:sp>
+        <p:nvSpPr>
+          <p:cNvPr id="47" name="Oval 46"/>
           <p:cNvSpPr/>
           <p:nvPr/>
         </p:nvSpPr>
@@ -6025,14 +5164,14 @@
       </p:sp>
       <p:sp>
         <p:nvSpPr>
-          <p:cNvPr id="69" name="TextBox 68"/>
+          <p:cNvPr id="48" name="TextBox 47"/>
           <p:cNvSpPr txBox="1"/>
           <p:nvPr/>
         </p:nvSpPr>
         <p:spPr>
           <a:xfrm>
-            <a:off x="10576560" y="5943600"/>
-            <a:ext cx="1310640" cy="457200"/>
+            <a:off x="8741664" y="5943600"/>
+            <a:ext cx="3145536" cy="457200"/>
           </a:xfrm>
           <a:prstGeom prst="rect">
             <a:avLst/>
@@ -6053,14 +5192,14 @@
                 </a:solidFill>
                 <a:latin typeface="Calibri"/>
               </a:rPr>
-              <a:t>M12: Control Tower</a:t>
-            </a:r>
-          </a:p>
-        </p:txBody>
-      </p:sp>
-      <p:sp>
-        <p:nvSpPr>
-          <p:cNvPr id="70" name="TextBox 69"/>
+              <a:t>M5: Control Tower</a:t>
+            </a:r>
+          </a:p>
+        </p:txBody>
+      </p:sp>
+      <p:sp>
+        <p:nvSpPr>
+          <p:cNvPr id="49" name="TextBox 48"/>
           <p:cNvSpPr txBox="1"/>
           <p:nvPr/>
         </p:nvSpPr>
@@ -6601,7 +5740,7 @@
                 </a:solidFill>
                 <a:latin typeface="Calibri"/>
               </a:rPr>
-              <a:t>(M1-M2)</a:t>
+              <a:t>(M1)</a:t>
             </a:r>
           </a:p>
         </p:txBody>
@@ -6854,7 +5993,7 @@
                 </a:solidFill>
                 <a:latin typeface="Calibri"/>
               </a:rPr>
-              <a:t>(M3)</a:t>
+              <a:t>(M2)</a:t>
             </a:r>
           </a:p>
         </p:txBody>
@@ -7095,7 +6234,7 @@
                 </a:solidFill>
                 <a:latin typeface="Calibri"/>
               </a:rPr>
-              <a:t>(M4-M5)</a:t>
+              <a:t>(M2-M3)</a:t>
             </a:r>
           </a:p>
         </p:txBody>
@@ -7336,7 +6475,7 @@
                 </a:solidFill>
                 <a:latin typeface="Calibri"/>
               </a:rPr>
-              <a:t>(M6-M7)</a:t>
+              <a:t>(M3-M4)</a:t>
             </a:r>
           </a:p>
         </p:txBody>
@@ -7577,7 +6716,7 @@
                 </a:solidFill>
                 <a:latin typeface="Calibri"/>
               </a:rPr>
-              <a:t>(M8-M9)</a:t>
+              <a:t>(M4)</a:t>
             </a:r>
           </a:p>
         </p:txBody>
@@ -7806,7 +6945,7 @@
                 </a:solidFill>
                 <a:latin typeface="Calibri"/>
               </a:rPr>
-              <a:t>(M10-M12)</a:t>
+              <a:t>(M4-M5)</a:t>
             </a:r>
           </a:p>
         </p:txBody>

</xml_diff>